<commit_message>
Add final presentation PDF and updated charts
</commit_message>
<xml_diff>
--- a/SpaceX_Capstone_Presentation.pptx
+++ b/SpaceX_Capstone_Presentation.pptx
@@ -6818,6 +6818,9 @@
               </a:rPr>
               <a:t>All notebooks (data collection, wrangling, EDA SQL, EDA viz, Folium, Dash, ML):</a:t>
             </a:r>
+            <a:endParaRPr lang="en-US" sz="1600" dirty="0"/>
+          </a:p>
+          <a:p>
             <a:pPr indent="0" marL="0">
               <a:lnSpc>
                 <a:spcPct val="140000"/>
@@ -6835,6 +6838,18 @@
               </a:rPr>
               <a:t>https://github.com/Pointsd/Applied-Data-Science-Capstone</a:t>
             </a:r>
+            <a:endParaRPr lang="en-US" sz="1600" dirty="0"/>
+          </a:p>
+          <a:p>
+            <a:pPr indent="0" marL="0">
+              <a:lnSpc>
+                <a:spcPct val="140000"/>
+              </a:lnSpc>
+              <a:buNone/>
+            </a:pPr>
+            <a:endParaRPr lang="en-US" sz="1600" dirty="0"/>
+          </a:p>
+          <a:p>
             <a:pPr indent="0" marL="0">
               <a:lnSpc>
                 <a:spcPct val="140000"/>

</xml_diff>